<commit_message>
P4, diapo 9 : le titre de la première carte tenait sur trois lignes
« Le module · 4 h, le matin, en groupe » : trois faits à 23 points dans une
colonne de 3,21 po, donc trois lignes dans une boîte qui en tient deux. Les
deux cartes voisines n'en portent que deux et tiennent sans peine.

Le fait retiré est « en groupe », et pas un autre : le contraste groupe /
seul est déjà porté par les corps des cartes — « L'enseignant est là » ici,
« Personne n'est à côté » sur la troisième — tandis que matin / après-midi
n'est écrit nulle part ailleurs que dans ces titres. Les trois se lisent
maintenant en parallèle : 4 h le matin, 2 h l'après-midi, 10 min seul.

Les deux sorties sont refaites, le .pptx et le HTML : corriger le script ne
refait pas le binaire, et c'est le binaire qu'on projette. Le contrôle des
diaporamas de la trousse repasse au vert sur les dix.

Co-Authored-By: Claude Opus 5 <noreply@anthropic.com>
</commit_message>
<xml_diff>
--- a/assets/presentations/diaporamas/P4-le-point-express.pptx
+++ b/assets/presentations/diaporamas/P4-le-point-express.pptx
@@ -11537,7 +11537,7 @@
         <p:spPr>
           <a:xfrm>
             <a:off x="886968" y="2084831"/>
-            <a:ext cx="2936138" cy="1061466"/>
+            <a:ext cx="2936138" cy="746760"/>
           </a:xfrm>
           <a:prstGeom prst="rect">
             <a:avLst/>
@@ -11556,13 +11556,13 @@
               </a:lnSpc>
             </a:pPr>
             <a:r>
-              <a:rPr sz="2300" b="1" i="0">
+              <a:rPr sz="2400" b="1" i="0">
                 <a:solidFill>
                   <a:srgbClr val="0D7A6F"/>
                 </a:solidFill>
                 <a:latin typeface="Verdana"/>
               </a:rPr>
-              <a:t>Le module · 4 h, le matin, en groupe</a:t>
+              <a:t>Le module · 4 h, le matin</a:t>
             </a:r>
           </a:p>
         </p:txBody>
@@ -11575,8 +11575,8 @@
         </p:nvSpPr>
         <p:spPr>
           <a:xfrm>
-            <a:off x="886968" y="3173730"/>
-            <a:ext cx="2936138" cy="2632710"/>
+            <a:off x="886968" y="2859024"/>
+            <a:ext cx="2936138" cy="2947416"/>
           </a:xfrm>
           <a:prstGeom prst="rect">
             <a:avLst/>
@@ -11661,7 +11661,7 @@
         <p:spPr>
           <a:xfrm>
             <a:off x="4627778" y="2084831"/>
-            <a:ext cx="2936138" cy="1061466"/>
+            <a:ext cx="2936138" cy="746760"/>
           </a:xfrm>
           <a:prstGeom prst="rect">
             <a:avLst/>
@@ -11680,7 +11680,7 @@
               </a:lnSpc>
             </a:pPr>
             <a:r>
-              <a:rPr sz="2300" b="1" i="0">
+              <a:rPr sz="2400" b="1" i="0">
                 <a:solidFill>
                   <a:srgbClr val="0D7A6F"/>
                 </a:solidFill>
@@ -11699,8 +11699,8 @@
         </p:nvSpPr>
         <p:spPr>
           <a:xfrm>
-            <a:off x="4627778" y="3173730"/>
-            <a:ext cx="2936138" cy="2632710"/>
+            <a:off x="4627778" y="2859024"/>
+            <a:ext cx="2936138" cy="2947416"/>
           </a:xfrm>
           <a:prstGeom prst="rect">
             <a:avLst/>
@@ -11785,7 +11785,7 @@
         <p:spPr>
           <a:xfrm>
             <a:off x="8368588" y="2084831"/>
-            <a:ext cx="2936138" cy="1061466"/>
+            <a:ext cx="2936138" cy="746760"/>
           </a:xfrm>
           <a:prstGeom prst="rect">
             <a:avLst/>
@@ -11804,7 +11804,7 @@
               </a:lnSpc>
             </a:pPr>
             <a:r>
-              <a:rPr sz="2300" b="1" i="0">
+              <a:rPr sz="2400" b="1" i="0">
                 <a:solidFill>
                   <a:srgbClr val="0D7A6F"/>
                 </a:solidFill>
@@ -11823,8 +11823,8 @@
         </p:nvSpPr>
         <p:spPr>
           <a:xfrm>
-            <a:off x="8368588" y="3173730"/>
-            <a:ext cx="2936138" cy="2632710"/>
+            <a:off x="8368588" y="2859024"/>
+            <a:ext cx="2936138" cy="2947416"/>
           </a:xfrm>
           <a:prstGeom prst="rect">
             <a:avLst/>

</xml_diff>